<commit_message>
Fuera el cronograma: la sesion queda en tres bloques
Conceptos, ejemplos y el hacer. Se quitan los minutos de la diapositiva de
ruta, del taller y de la puesta en comun; las notas del docente pierden la
marca de reloj y el enunciado del taller pasa de minuto a minuto a cuatro
pasos numerados, con una nota de que recortar si el tiempo aprieta.

En la presentacion web desaparecen el reloj de sesion y los minutos del
indice; el cronometro del taller se queda, ajustable en tramos de cinco
minutos, porque el docente decide en el momento cuanto tiempo le queda.
</commit_message>
<xml_diff>
--- a/fuentes/AREM_S3_Deck_Reto_U3_sin_notas.pptx
+++ b/fuentes/AREM_S3_Deck_Reto_U3_sin_notas.pptx
@@ -11869,7 +11869,7 @@
                 </a:solidFill>
                 <a:latin typeface="Calibri"/>
               </a:rPr>
-              <a:t>BLOQUE 3 · TALLER EN SALAS · 27 MINUTOS</a:t>
+              <a:t>EL HACER · TALLER EN SALAS</a:t>
             </a:r>
           </a:p>
         </p:txBody>
@@ -12065,7 +12065,7 @@
                 </a:solidFill>
                 <a:latin typeface="Calibri"/>
               </a:rPr>
-              <a:t>Minutos 0 a 5 · Elijan el episodio</a:t>
+              <a:t>1 · Elijan el episodio</a:t>
             </a:r>
           </a:p>
           <a:p>
@@ -12243,7 +12243,7 @@
                 </a:solidFill>
                 <a:latin typeface="Calibri"/>
               </a:rPr>
-              <a:t>Minutos 5 a 12 · El principio (F-23)</a:t>
+              <a:t>2 · El principio (F-23)</a:t>
             </a:r>
           </a:p>
           <a:p>
@@ -12421,7 +12421,7 @@
                 </a:solidFill>
                 <a:latin typeface="Calibri"/>
               </a:rPr>
-              <a:t>Minutos 12 a 20 · La pregunta y el dictamen (F-24)</a:t>
+              <a:t>3 · La pregunta y el dictamen (F-24)</a:t>
             </a:r>
           </a:p>
           <a:p>
@@ -12599,7 +12599,7 @@
                 </a:solidFill>
                 <a:latin typeface="Calibri"/>
               </a:rPr>
-              <a:t>Minutos 20 a 27 · Las sillas (F-22)</a:t>
+              <a:t>4 · Las sillas (F-22)</a:t>
             </a:r>
           </a:p>
           <a:p>
@@ -14733,7 +14733,7 @@
                 </a:solidFill>
                 <a:latin typeface="Calibri"/>
               </a:rPr>
-              <a:t>PUESTA EN COMÚN · 12 MINUTOS</a:t>
+              <a:t>PUESTA EN COMÚN</a:t>
             </a:r>
           </a:p>
         </p:txBody>
@@ -16920,7 +16920,7 @@
         </p:nvSpPr>
         <p:spPr>
           <a:xfrm>
-            <a:off x="685800" y="1645920"/>
+            <a:off x="685800" y="1737360"/>
             <a:ext cx="3454298" cy="73152"/>
           </a:xfrm>
           <a:prstGeom prst="rect">
@@ -16964,7 +16964,7 @@
         </p:nvSpPr>
         <p:spPr>
           <a:xfrm>
-            <a:off x="685800" y="1828800"/>
+            <a:off x="685800" y="1920240"/>
             <a:ext cx="3454298" cy="274320"/>
           </a:xfrm>
           <a:prstGeom prst="rect">
@@ -16985,7 +16985,7 @@
                 </a:solidFill>
                 <a:latin typeface="Calibri"/>
               </a:rPr>
-              <a:t>BLOQUE 1 · 20 MIN</a:t>
+              <a:t>PRIMERO</a:t>
             </a:r>
           </a:p>
         </p:txBody>
@@ -16998,7 +16998,7 @@
         </p:nvSpPr>
         <p:spPr>
           <a:xfrm>
-            <a:off x="685800" y="2148840"/>
+            <a:off x="685800" y="2240280"/>
             <a:ext cx="3454298" cy="457200"/>
           </a:xfrm>
           <a:prstGeom prst="rect">
@@ -17019,7 +17019,7 @@
                 </a:solidFill>
                 <a:latin typeface="Cambria"/>
               </a:rPr>
-              <a:t>Qué significa</a:t>
+              <a:t>Conceptos</a:t>
             </a:r>
           </a:p>
         </p:txBody>
@@ -17032,7 +17032,7 @@
         </p:nvSpPr>
         <p:spPr>
           <a:xfrm>
-            <a:off x="685800" y="2788920"/>
+            <a:off x="685800" y="2880360"/>
             <a:ext cx="3454298" cy="1097280"/>
           </a:xfrm>
           <a:prstGeom prst="rect">
@@ -17066,7 +17066,7 @@
         </p:nvSpPr>
         <p:spPr>
           <a:xfrm>
-            <a:off x="4368698" y="1645920"/>
+            <a:off x="4368698" y="1737360"/>
             <a:ext cx="3454298" cy="73152"/>
           </a:xfrm>
           <a:prstGeom prst="rect">
@@ -17110,7 +17110,7 @@
         </p:nvSpPr>
         <p:spPr>
           <a:xfrm>
-            <a:off x="4368698" y="1828800"/>
+            <a:off x="4368698" y="1920240"/>
             <a:ext cx="3454298" cy="274320"/>
           </a:xfrm>
           <a:prstGeom prst="rect">
@@ -17131,7 +17131,7 @@
                 </a:solidFill>
                 <a:latin typeface="Calibri"/>
               </a:rPr>
-              <a:t>BLOQUE 2 · 25 MIN</a:t>
+              <a:t>DESPUÉS</a:t>
             </a:r>
           </a:p>
         </p:txBody>
@@ -17144,7 +17144,7 @@
         </p:nvSpPr>
         <p:spPr>
           <a:xfrm>
-            <a:off x="4368698" y="2148840"/>
+            <a:off x="4368698" y="2240280"/>
             <a:ext cx="3454298" cy="457200"/>
           </a:xfrm>
           <a:prstGeom prst="rect">
@@ -17165,7 +17165,7 @@
                 </a:solidFill>
                 <a:latin typeface="Cambria"/>
               </a:rPr>
-              <a:t>Ejemplos guiados</a:t>
+              <a:t>Ejemplos</a:t>
             </a:r>
           </a:p>
         </p:txBody>
@@ -17178,7 +17178,7 @@
         </p:nvSpPr>
         <p:spPr>
           <a:xfrm>
-            <a:off x="4368698" y="2788920"/>
+            <a:off x="4368698" y="2880360"/>
             <a:ext cx="3454298" cy="1097280"/>
           </a:xfrm>
           <a:prstGeom prst="rect">
@@ -17212,7 +17212,7 @@
         </p:nvSpPr>
         <p:spPr>
           <a:xfrm>
-            <a:off x="8051596" y="1645920"/>
+            <a:off x="8051596" y="1737360"/>
             <a:ext cx="3454298" cy="73152"/>
           </a:xfrm>
           <a:prstGeom prst="rect">
@@ -17256,7 +17256,7 @@
         </p:nvSpPr>
         <p:spPr>
           <a:xfrm>
-            <a:off x="8051596" y="1828800"/>
+            <a:off x="8051596" y="1920240"/>
             <a:ext cx="3454298" cy="274320"/>
           </a:xfrm>
           <a:prstGeom prst="rect">
@@ -17277,7 +17277,7 @@
                 </a:solidFill>
                 <a:latin typeface="Calibri"/>
               </a:rPr>
-              <a:t>BLOQUE 3 · 48 MIN</a:t>
+              <a:t>Y EL RESTO DE LA SESIÓN</a:t>
             </a:r>
           </a:p>
         </p:txBody>
@@ -17290,7 +17290,7 @@
         </p:nvSpPr>
         <p:spPr>
           <a:xfrm>
-            <a:off x="8051596" y="2148840"/>
+            <a:off x="8051596" y="2240280"/>
             <a:ext cx="3454298" cy="457200"/>
           </a:xfrm>
           <a:prstGeom prst="rect">
@@ -17311,7 +17311,7 @@
                 </a:solidFill>
                 <a:latin typeface="Cambria"/>
               </a:rPr>
-              <a:t>Ustedes</a:t>
+              <a:t>El hacer</a:t>
             </a:r>
           </a:p>
         </p:txBody>
@@ -17324,7 +17324,7 @@
         </p:nvSpPr>
         <p:spPr>
           <a:xfrm>
-            <a:off x="8051596" y="2788920"/>
+            <a:off x="8051596" y="2880360"/>
             <a:ext cx="3454298" cy="1097280"/>
           </a:xfrm>
           <a:prstGeom prst="rect">
@@ -17345,7 +17345,7 @@
                 </a:solidFill>
                 <a:latin typeface="Calibri"/>
               </a:rPr>
-              <a:t>Un taller en salas de 27 minutos, la puesta en común y el cierre.</a:t>
+              <a:t>El taller en salas sobre su propio caso, la puesta en común y el cierre.</a:t>
             </a:r>
           </a:p>
         </p:txBody>
@@ -17358,8 +17358,8 @@
         </p:nvSpPr>
         <p:spPr>
           <a:xfrm>
-            <a:off x="685800" y="3977639"/>
-            <a:ext cx="1737358" cy="356616"/>
+            <a:off x="685800" y="4480560"/>
+            <a:ext cx="10820095" cy="868680"/>
           </a:xfrm>
           <a:prstGeom prst="rect">
             <a:avLst/>
@@ -17402,753 +17402,35 @@
         </p:nvSpPr>
         <p:spPr>
           <a:xfrm>
-            <a:off x="777240" y="4032503"/>
-            <a:ext cx="1554480" cy="356616"/>
-          </a:xfrm>
-          <a:prstGeom prst="rect">
-            <a:avLst/>
-          </a:prstGeom>
-          <a:noFill/>
-        </p:spPr>
-        <p:txBody>
-          <a:bodyPr wrap="square" lIns="0" rIns="0" tIns="0" bIns="0">
-            <a:spAutoFit/>
-          </a:bodyPr>
-          <a:lstStyle/>
-          <a:p>
-            <a:r>
-              <a:rPr sz="1200" b="1">
+            <a:off x="1051560" y="4636008"/>
+            <a:ext cx="10088575" cy="594359"/>
+          </a:xfrm>
+          <a:prstGeom prst="rect">
+            <a:avLst/>
+          </a:prstGeom>
+          <a:noFill/>
+        </p:spPr>
+        <p:txBody>
+          <a:bodyPr wrap="square" lIns="0" rIns="0" tIns="0" bIns="0" anchor="ctr">
+            <a:spAutoFit/>
+          </a:bodyPr>
+          <a:lstStyle/>
+          <a:p>
+            <a:r>
+              <a:rPr sz="1500" b="0">
                 <a:solidFill>
                   <a:srgbClr val="FFFFFF"/>
                 </a:solidFill>
-                <a:latin typeface="Calibri"/>
-              </a:rPr>
-              <a:t>Minuto</a:t>
-            </a:r>
-          </a:p>
-        </p:txBody>
-      </p:sp>
-      <p:sp>
-        <p:nvSpPr>
-          <p:cNvPr id="18" name="Rectangle 17"/>
-          <p:cNvSpPr/>
-          <p:nvPr/>
-        </p:nvSpPr>
-        <p:spPr>
-          <a:xfrm>
-            <a:off x="2423160" y="3977639"/>
-            <a:ext cx="9079990" cy="356616"/>
-          </a:xfrm>
-          <a:prstGeom prst="rect">
-            <a:avLst/>
-          </a:prstGeom>
-          <a:solidFill>
-            <a:srgbClr val="1C2B33"/>
-          </a:solidFill>
-          <a:ln>
-            <a:noFill/>
-          </a:ln>
-          <a:effectLst/>
-        </p:spPr>
-        <p:style>
-          <a:lnRef idx="1">
-            <a:schemeClr val="accent1"/>
-          </a:lnRef>
-          <a:fillRef idx="3">
-            <a:schemeClr val="accent1"/>
-          </a:fillRef>
-          <a:effectRef idx="2">
-            <a:schemeClr val="accent1"/>
-          </a:effectRef>
-          <a:fontRef idx="minor">
-            <a:schemeClr val="lt1"/>
-          </a:fontRef>
-        </p:style>
-        <p:txBody>
-          <a:bodyPr rtlCol="0" anchor="ctr"/>
-          <a:lstStyle/>
-          <a:p>
-            <a:pPr algn="ctr"/>
-          </a:p>
-        </p:txBody>
-      </p:sp>
-      <p:sp>
-        <p:nvSpPr>
-          <p:cNvPr id="19" name="TextBox 18"/>
-          <p:cNvSpPr txBox="1"/>
-          <p:nvPr/>
-        </p:nvSpPr>
-        <p:spPr>
-          <a:xfrm>
-            <a:off x="2514600" y="4032503"/>
-            <a:ext cx="8897112" cy="356616"/>
-          </a:xfrm>
-          <a:prstGeom prst="rect">
-            <a:avLst/>
-          </a:prstGeom>
-          <a:noFill/>
-        </p:spPr>
-        <p:txBody>
-          <a:bodyPr wrap="square" lIns="0" rIns="0" tIns="0" bIns="0">
-            <a:spAutoFit/>
-          </a:bodyPr>
-          <a:lstStyle/>
-          <a:p>
-            <a:r>
-              <a:rPr sz="1200" b="1">
-                <a:solidFill>
-                  <a:srgbClr val="FFFFFF"/>
-                </a:solidFill>
-                <a:latin typeface="Calibri"/>
-              </a:rPr>
-              <a:t>Qué pasa</a:t>
-            </a:r>
-          </a:p>
-        </p:txBody>
-      </p:sp>
-      <p:sp>
-        <p:nvSpPr>
-          <p:cNvPr id="20" name="Rectangle 19"/>
-          <p:cNvSpPr/>
-          <p:nvPr/>
-        </p:nvSpPr>
-        <p:spPr>
-          <a:xfrm>
-            <a:off x="685800" y="4334255"/>
-            <a:ext cx="1737358" cy="356614"/>
-          </a:xfrm>
-          <a:prstGeom prst="rect">
-            <a:avLst/>
-          </a:prstGeom>
-          <a:solidFill>
-            <a:srgbClr val="EFF2F3"/>
-          </a:solidFill>
-          <a:ln>
-            <a:solidFill>
-              <a:srgbClr val="CFDAE0"/>
-            </a:solidFill>
-          </a:ln>
-          <a:effectLst/>
-        </p:spPr>
-        <p:style>
-          <a:lnRef idx="1">
-            <a:schemeClr val="accent1"/>
-          </a:lnRef>
-          <a:fillRef idx="3">
-            <a:schemeClr val="accent1"/>
-          </a:fillRef>
-          <a:effectRef idx="2">
-            <a:schemeClr val="accent1"/>
-          </a:effectRef>
-          <a:fontRef idx="minor">
-            <a:schemeClr val="lt1"/>
-          </a:fontRef>
-        </p:style>
-        <p:txBody>
-          <a:bodyPr rtlCol="0" anchor="ctr"/>
-          <a:lstStyle/>
-          <a:p>
-            <a:pPr algn="ctr"/>
-          </a:p>
-        </p:txBody>
-      </p:sp>
-      <p:sp>
-        <p:nvSpPr>
-          <p:cNvPr id="21" name="TextBox 20"/>
-          <p:cNvSpPr txBox="1"/>
-          <p:nvPr/>
-        </p:nvSpPr>
-        <p:spPr>
-          <a:xfrm>
-            <a:off x="777240" y="4389119"/>
-            <a:ext cx="1554480" cy="265176"/>
-          </a:xfrm>
-          <a:prstGeom prst="rect">
-            <a:avLst/>
-          </a:prstGeom>
-          <a:noFill/>
-        </p:spPr>
-        <p:txBody>
-          <a:bodyPr wrap="square" lIns="0" rIns="0" tIns="0" bIns="0">
-            <a:spAutoFit/>
-          </a:bodyPr>
-          <a:lstStyle/>
-          <a:p>
-            <a:r>
-              <a:rPr sz="1200" b="1">
-                <a:solidFill>
-                  <a:srgbClr val="31424B"/>
-                </a:solidFill>
-                <a:latin typeface="Calibri"/>
-              </a:rPr>
-              <a:t>0 a 25</a:t>
-            </a:r>
-          </a:p>
-        </p:txBody>
-      </p:sp>
-      <p:sp>
-        <p:nvSpPr>
-          <p:cNvPr id="22" name="Rectangle 21"/>
-          <p:cNvSpPr/>
-          <p:nvPr/>
-        </p:nvSpPr>
-        <p:spPr>
-          <a:xfrm>
-            <a:off x="2423160" y="4334255"/>
-            <a:ext cx="9079990" cy="356614"/>
-          </a:xfrm>
-          <a:prstGeom prst="rect">
-            <a:avLst/>
-          </a:prstGeom>
-          <a:solidFill>
-            <a:srgbClr val="EFF2F3"/>
-          </a:solidFill>
-          <a:ln>
-            <a:solidFill>
-              <a:srgbClr val="CFDAE0"/>
-            </a:solidFill>
-          </a:ln>
-          <a:effectLst/>
-        </p:spPr>
-        <p:style>
-          <a:lnRef idx="1">
-            <a:schemeClr val="accent1"/>
-          </a:lnRef>
-          <a:fillRef idx="3">
-            <a:schemeClr val="accent1"/>
-          </a:fillRef>
-          <a:effectRef idx="2">
-            <a:schemeClr val="accent1"/>
-          </a:effectRef>
-          <a:fontRef idx="minor">
-            <a:schemeClr val="lt1"/>
-          </a:fontRef>
-        </p:style>
-        <p:txBody>
-          <a:bodyPr rtlCol="0" anchor="ctr"/>
-          <a:lstStyle/>
-          <a:p>
-            <a:pPr algn="ctr"/>
-          </a:p>
-        </p:txBody>
-      </p:sp>
-      <p:sp>
-        <p:nvSpPr>
-          <p:cNvPr id="23" name="TextBox 22"/>
-          <p:cNvSpPr txBox="1"/>
-          <p:nvPr/>
-        </p:nvSpPr>
-        <p:spPr>
-          <a:xfrm>
-            <a:off x="2514600" y="4389119"/>
-            <a:ext cx="8897112" cy="265176"/>
-          </a:xfrm>
-          <a:prstGeom prst="rect">
-            <a:avLst/>
-          </a:prstGeom>
-          <a:noFill/>
-        </p:spPr>
-        <p:txBody>
-          <a:bodyPr wrap="square" lIns="0" rIns="0" tIns="0" bIns="0">
-            <a:spAutoFit/>
-          </a:bodyPr>
-          <a:lstStyle/>
-          <a:p>
-            <a:r>
-              <a:rPr sz="1200" b="0">
-                <a:solidFill>
-                  <a:srgbClr val="31424B"/>
-                </a:solidFill>
-                <a:latin typeface="Calibri"/>
-              </a:rPr>
-              <a:t>El reto y el significado del gobierno arquitectónico</a:t>
-            </a:r>
-          </a:p>
-        </p:txBody>
-      </p:sp>
-      <p:sp>
-        <p:nvSpPr>
-          <p:cNvPr id="24" name="Rectangle 23"/>
-          <p:cNvSpPr/>
-          <p:nvPr/>
-        </p:nvSpPr>
-        <p:spPr>
-          <a:xfrm>
-            <a:off x="685800" y="4690871"/>
-            <a:ext cx="1737358" cy="356614"/>
-          </a:xfrm>
-          <a:prstGeom prst="rect">
-            <a:avLst/>
-          </a:prstGeom>
-          <a:solidFill>
-            <a:srgbClr val="FFFFFF"/>
-          </a:solidFill>
-          <a:ln>
-            <a:solidFill>
-              <a:srgbClr val="CFDAE0"/>
-            </a:solidFill>
-          </a:ln>
-          <a:effectLst/>
-        </p:spPr>
-        <p:style>
-          <a:lnRef idx="1">
-            <a:schemeClr val="accent1"/>
-          </a:lnRef>
-          <a:fillRef idx="3">
-            <a:schemeClr val="accent1"/>
-          </a:fillRef>
-          <a:effectRef idx="2">
-            <a:schemeClr val="accent1"/>
-          </a:effectRef>
-          <a:fontRef idx="minor">
-            <a:schemeClr val="lt1"/>
-          </a:fontRef>
-        </p:style>
-        <p:txBody>
-          <a:bodyPr rtlCol="0" anchor="ctr"/>
-          <a:lstStyle/>
-          <a:p>
-            <a:pPr algn="ctr"/>
-          </a:p>
-        </p:txBody>
-      </p:sp>
-      <p:sp>
-        <p:nvSpPr>
-          <p:cNvPr id="25" name="TextBox 24"/>
-          <p:cNvSpPr txBox="1"/>
-          <p:nvPr/>
-        </p:nvSpPr>
-        <p:spPr>
-          <a:xfrm>
-            <a:off x="777240" y="4745735"/>
-            <a:ext cx="1554480" cy="265176"/>
-          </a:xfrm>
-          <a:prstGeom prst="rect">
-            <a:avLst/>
-          </a:prstGeom>
-          <a:noFill/>
-        </p:spPr>
-        <p:txBody>
-          <a:bodyPr wrap="square" lIns="0" rIns="0" tIns="0" bIns="0">
-            <a:spAutoFit/>
-          </a:bodyPr>
-          <a:lstStyle/>
-          <a:p>
-            <a:r>
-              <a:rPr sz="1200" b="1">
-                <a:solidFill>
-                  <a:srgbClr val="31424B"/>
-                </a:solidFill>
-                <a:latin typeface="Calibri"/>
-              </a:rPr>
-              <a:t>25 a 32</a:t>
-            </a:r>
-          </a:p>
-        </p:txBody>
-      </p:sp>
-      <p:sp>
-        <p:nvSpPr>
-          <p:cNvPr id="26" name="Rectangle 25"/>
-          <p:cNvSpPr/>
-          <p:nvPr/>
-        </p:nvSpPr>
-        <p:spPr>
-          <a:xfrm>
-            <a:off x="2423160" y="4690871"/>
-            <a:ext cx="9079990" cy="356614"/>
-          </a:xfrm>
-          <a:prstGeom prst="rect">
-            <a:avLst/>
-          </a:prstGeom>
-          <a:solidFill>
-            <a:srgbClr val="FFFFFF"/>
-          </a:solidFill>
-          <a:ln>
-            <a:solidFill>
-              <a:srgbClr val="CFDAE0"/>
-            </a:solidFill>
-          </a:ln>
-          <a:effectLst/>
-        </p:spPr>
-        <p:style>
-          <a:lnRef idx="1">
-            <a:schemeClr val="accent1"/>
-          </a:lnRef>
-          <a:fillRef idx="3">
-            <a:schemeClr val="accent1"/>
-          </a:fillRef>
-          <a:effectRef idx="2">
-            <a:schemeClr val="accent1"/>
-          </a:effectRef>
-          <a:fontRef idx="minor">
-            <a:schemeClr val="lt1"/>
-          </a:fontRef>
-        </p:style>
-        <p:txBody>
-          <a:bodyPr rtlCol="0" anchor="ctr"/>
-          <a:lstStyle/>
-          <a:p>
-            <a:pPr algn="ctr"/>
-          </a:p>
-        </p:txBody>
-      </p:sp>
-      <p:sp>
-        <p:nvSpPr>
-          <p:cNvPr id="27" name="TextBox 26"/>
-          <p:cNvSpPr txBox="1"/>
-          <p:nvPr/>
-        </p:nvSpPr>
-        <p:spPr>
-          <a:xfrm>
-            <a:off x="2514600" y="4745735"/>
-            <a:ext cx="8897112" cy="265176"/>
-          </a:xfrm>
-          <a:prstGeom prst="rect">
-            <a:avLst/>
-          </a:prstGeom>
-          <a:noFill/>
-        </p:spPr>
-        <p:txBody>
-          <a:bodyPr wrap="square" lIns="0" rIns="0" tIns="0" bIns="0">
-            <a:spAutoFit/>
-          </a:bodyPr>
-          <a:lstStyle/>
-          <a:p>
-            <a:r>
-              <a:rPr sz="1200" b="0">
-                <a:solidFill>
-                  <a:srgbClr val="31424B"/>
-                </a:solidFill>
-                <a:latin typeface="Calibri"/>
-              </a:rPr>
-              <a:t>La Actividad 3.1, guiada · pausa de 15 minutos</a:t>
-            </a:r>
-          </a:p>
-        </p:txBody>
-      </p:sp>
-      <p:sp>
-        <p:nvSpPr>
-          <p:cNvPr id="28" name="Rectangle 27"/>
-          <p:cNvSpPr/>
-          <p:nvPr/>
-        </p:nvSpPr>
-        <p:spPr>
-          <a:xfrm>
-            <a:off x="685800" y="5047487"/>
-            <a:ext cx="1737358" cy="356614"/>
-          </a:xfrm>
-          <a:prstGeom prst="rect">
-            <a:avLst/>
-          </a:prstGeom>
-          <a:solidFill>
-            <a:srgbClr val="EFF2F3"/>
-          </a:solidFill>
-          <a:ln>
-            <a:solidFill>
-              <a:srgbClr val="CFDAE0"/>
-            </a:solidFill>
-          </a:ln>
-          <a:effectLst/>
-        </p:spPr>
-        <p:style>
-          <a:lnRef idx="1">
-            <a:schemeClr val="accent1"/>
-          </a:lnRef>
-          <a:fillRef idx="3">
-            <a:schemeClr val="accent1"/>
-          </a:fillRef>
-          <a:effectRef idx="2">
-            <a:schemeClr val="accent1"/>
-          </a:effectRef>
-          <a:fontRef idx="minor">
-            <a:schemeClr val="lt1"/>
-          </a:fontRef>
-        </p:style>
-        <p:txBody>
-          <a:bodyPr rtlCol="0" anchor="ctr"/>
-          <a:lstStyle/>
-          <a:p>
-            <a:pPr algn="ctr"/>
-          </a:p>
-        </p:txBody>
-      </p:sp>
-      <p:sp>
-        <p:nvSpPr>
-          <p:cNvPr id="29" name="TextBox 28"/>
-          <p:cNvSpPr txBox="1"/>
-          <p:nvPr/>
-        </p:nvSpPr>
-        <p:spPr>
-          <a:xfrm>
-            <a:off x="777240" y="5102351"/>
-            <a:ext cx="1554480" cy="265176"/>
-          </a:xfrm>
-          <a:prstGeom prst="rect">
-            <a:avLst/>
-          </a:prstGeom>
-          <a:noFill/>
-        </p:spPr>
-        <p:txBody>
-          <a:bodyPr wrap="square" lIns="0" rIns="0" tIns="0" bIns="0">
-            <a:spAutoFit/>
-          </a:bodyPr>
-          <a:lstStyle/>
-          <a:p>
-            <a:r>
-              <a:rPr sz="1200" b="1">
-                <a:solidFill>
-                  <a:srgbClr val="31424B"/>
-                </a:solidFill>
-                <a:latin typeface="Calibri"/>
-              </a:rPr>
-              <a:t>47 a 72</a:t>
-            </a:r>
-          </a:p>
-        </p:txBody>
-      </p:sp>
-      <p:sp>
-        <p:nvSpPr>
-          <p:cNvPr id="30" name="Rectangle 29"/>
-          <p:cNvSpPr/>
-          <p:nvPr/>
-        </p:nvSpPr>
-        <p:spPr>
-          <a:xfrm>
-            <a:off x="2423160" y="5047487"/>
-            <a:ext cx="9079990" cy="356614"/>
-          </a:xfrm>
-          <a:prstGeom prst="rect">
-            <a:avLst/>
-          </a:prstGeom>
-          <a:solidFill>
-            <a:srgbClr val="EFF2F3"/>
-          </a:solidFill>
-          <a:ln>
-            <a:solidFill>
-              <a:srgbClr val="CFDAE0"/>
-            </a:solidFill>
-          </a:ln>
-          <a:effectLst/>
-        </p:spPr>
-        <p:style>
-          <a:lnRef idx="1">
-            <a:schemeClr val="accent1"/>
-          </a:lnRef>
-          <a:fillRef idx="3">
-            <a:schemeClr val="accent1"/>
-          </a:fillRef>
-          <a:effectRef idx="2">
-            <a:schemeClr val="accent1"/>
-          </a:effectRef>
-          <a:fontRef idx="minor">
-            <a:schemeClr val="lt1"/>
-          </a:fontRef>
-        </p:style>
-        <p:txBody>
-          <a:bodyPr rtlCol="0" anchor="ctr"/>
-          <a:lstStyle/>
-          <a:p>
-            <a:pPr algn="ctr"/>
-          </a:p>
-        </p:txBody>
-      </p:sp>
-      <p:sp>
-        <p:nvSpPr>
-          <p:cNvPr id="31" name="TextBox 30"/>
-          <p:cNvSpPr txBox="1"/>
-          <p:nvPr/>
-        </p:nvSpPr>
-        <p:spPr>
-          <a:xfrm>
-            <a:off x="2514600" y="5102351"/>
-            <a:ext cx="8897112" cy="265176"/>
-          </a:xfrm>
-          <a:prstGeom prst="rect">
-            <a:avLst/>
-          </a:prstGeom>
-          <a:noFill/>
-        </p:spPr>
-        <p:txBody>
-          <a:bodyPr wrap="square" lIns="0" rIns="0" tIns="0" bIns="0">
-            <a:spAutoFit/>
-          </a:bodyPr>
-          <a:lstStyle/>
-          <a:p>
-            <a:r>
-              <a:rPr sz="1200" b="0">
-                <a:solidFill>
-                  <a:srgbClr val="31424B"/>
-                </a:solidFill>
-                <a:latin typeface="Calibri"/>
-              </a:rPr>
-              <a:t>Ejemplos guiados de la 3.2: del episodio al principio, a la pregunta y a la silla del ARB</a:t>
-            </a:r>
-          </a:p>
-        </p:txBody>
-      </p:sp>
-      <p:sp>
-        <p:nvSpPr>
-          <p:cNvPr id="32" name="Rectangle 31"/>
-          <p:cNvSpPr/>
-          <p:nvPr/>
-        </p:nvSpPr>
-        <p:spPr>
-          <a:xfrm>
-            <a:off x="685800" y="5404103"/>
-            <a:ext cx="1737358" cy="356614"/>
-          </a:xfrm>
-          <a:prstGeom prst="rect">
-            <a:avLst/>
-          </a:prstGeom>
-          <a:solidFill>
-            <a:srgbClr val="FFFFFF"/>
-          </a:solidFill>
-          <a:ln>
-            <a:solidFill>
-              <a:srgbClr val="CFDAE0"/>
-            </a:solidFill>
-          </a:ln>
-          <a:effectLst/>
-        </p:spPr>
-        <p:style>
-          <a:lnRef idx="1">
-            <a:schemeClr val="accent1"/>
-          </a:lnRef>
-          <a:fillRef idx="3">
-            <a:schemeClr val="accent1"/>
-          </a:fillRef>
-          <a:effectRef idx="2">
-            <a:schemeClr val="accent1"/>
-          </a:effectRef>
-          <a:fontRef idx="minor">
-            <a:schemeClr val="lt1"/>
-          </a:fontRef>
-        </p:style>
-        <p:txBody>
-          <a:bodyPr rtlCol="0" anchor="ctr"/>
-          <a:lstStyle/>
-          <a:p>
-            <a:pPr algn="ctr"/>
-          </a:p>
-        </p:txBody>
-      </p:sp>
-      <p:sp>
-        <p:nvSpPr>
-          <p:cNvPr id="33" name="TextBox 32"/>
-          <p:cNvSpPr txBox="1"/>
-          <p:nvPr/>
-        </p:nvSpPr>
-        <p:spPr>
-          <a:xfrm>
-            <a:off x="777240" y="5458967"/>
-            <a:ext cx="1554480" cy="265176"/>
-          </a:xfrm>
-          <a:prstGeom prst="rect">
-            <a:avLst/>
-          </a:prstGeom>
-          <a:noFill/>
-        </p:spPr>
-        <p:txBody>
-          <a:bodyPr wrap="square" lIns="0" rIns="0" tIns="0" bIns="0">
-            <a:spAutoFit/>
-          </a:bodyPr>
-          <a:lstStyle/>
-          <a:p>
-            <a:r>
-              <a:rPr sz="1200" b="1">
-                <a:solidFill>
-                  <a:srgbClr val="31424B"/>
-                </a:solidFill>
-                <a:latin typeface="Calibri"/>
-              </a:rPr>
-              <a:t>72 a 120</a:t>
-            </a:r>
-          </a:p>
-        </p:txBody>
-      </p:sp>
-      <p:sp>
-        <p:nvSpPr>
-          <p:cNvPr id="34" name="Rectangle 33"/>
-          <p:cNvSpPr/>
-          <p:nvPr/>
-        </p:nvSpPr>
-        <p:spPr>
-          <a:xfrm>
-            <a:off x="2423160" y="5404103"/>
-            <a:ext cx="9079990" cy="356614"/>
-          </a:xfrm>
-          <a:prstGeom prst="rect">
-            <a:avLst/>
-          </a:prstGeom>
-          <a:solidFill>
-            <a:srgbClr val="FFFFFF"/>
-          </a:solidFill>
-          <a:ln>
-            <a:solidFill>
-              <a:srgbClr val="CFDAE0"/>
-            </a:solidFill>
-          </a:ln>
-          <a:effectLst/>
-        </p:spPr>
-        <p:style>
-          <a:lnRef idx="1">
-            <a:schemeClr val="accent1"/>
-          </a:lnRef>
-          <a:fillRef idx="3">
-            <a:schemeClr val="accent1"/>
-          </a:fillRef>
-          <a:effectRef idx="2">
-            <a:schemeClr val="accent1"/>
-          </a:effectRef>
-          <a:fontRef idx="minor">
-            <a:schemeClr val="lt1"/>
-          </a:fontRef>
-        </p:style>
-        <p:txBody>
-          <a:bodyPr rtlCol="0" anchor="ctr"/>
-          <a:lstStyle/>
-          <a:p>
-            <a:pPr algn="ctr"/>
-          </a:p>
-        </p:txBody>
-      </p:sp>
-      <p:sp>
-        <p:nvSpPr>
-          <p:cNvPr id="35" name="TextBox 34"/>
-          <p:cNvSpPr txBox="1"/>
-          <p:nvPr/>
-        </p:nvSpPr>
-        <p:spPr>
-          <a:xfrm>
-            <a:off x="2514600" y="5458967"/>
-            <a:ext cx="8897112" cy="265176"/>
-          </a:xfrm>
-          <a:prstGeom prst="rect">
-            <a:avLst/>
-          </a:prstGeom>
-          <a:noFill/>
-        </p:spPr>
-        <p:txBody>
-          <a:bodyPr wrap="square" lIns="0" rIns="0" tIns="0" bIns="0">
-            <a:spAutoFit/>
-          </a:bodyPr>
-          <a:lstStyle/>
-          <a:p>
-            <a:r>
-              <a:rPr sz="1200" b="0">
-                <a:solidFill>
-                  <a:srgbClr val="31424B"/>
-                </a:solidFill>
-                <a:latin typeface="Calibri"/>
-              </a:rPr>
-              <a:t>Taller en salas (27 min), puesta en común (12 min) y cierre</a:t>
-            </a:r>
-          </a:p>
-        </p:txBody>
-      </p:sp>
-      <p:sp>
-        <p:nvSpPr>
-          <p:cNvPr id="36" name="TextBox 35"/>
+                <a:latin typeface="Cambria"/>
+              </a:rPr>
+              <a:t>El bloque que no se recorta es el tercero. Si los conceptos se alargan, se acortan los ejemplos: están todos en el repositorio para verlos después.</a:t>
+            </a:r>
+          </a:p>
+        </p:txBody>
+      </p:sp>
+      <p:sp>
+        <p:nvSpPr>
+          <p:cNvPr id="18" name="TextBox 17"/>
           <p:cNvSpPr txBox="1"/>
           <p:nvPr/>
         </p:nvSpPr>
@@ -18175,7 +17457,7 @@
                 </a:solidFill>
                 <a:latin typeface="Calibri"/>
               </a:rPr>
-              <a:t>Una sola actividad en salas, al final: el resto de la sesión es para llegar a ella sabiendo qué hacer.</a:t>
+              <a:t>Una sola actividad en salas: el resto de la sesión es para llegar a ella sabiendo qué hacer.</a:t>
             </a:r>
           </a:p>
         </p:txBody>
@@ -24041,7 +23323,7 @@
                 </a:solidFill>
                 <a:latin typeface="Cambria"/>
               </a:rPr>
-              <a:t>Pausa de quince minutos. Volvemos en punto: al regresar empiezan los ejemplos guiados de la 3.2.</a:t>
+              <a:t>Pausa. Al regresar empiezan los ejemplos guiados de la 3.2.</a:t>
             </a:r>
           </a:p>
         </p:txBody>

</xml_diff>